<commit_message>
Add /plans planning agent (orchestrator + 3 sub-agents + workspace UI)
Backend: Plan/PlanSection models, backend/planning/ package
(orchestrator + sub_cases/sub_contacts/sub_brief + prompts),
routes_plans.py with list/create/get/stream/delete endpoints, and
orchestrator unit tests with a fake Anthropic client.

Frontend: /plans page with PlansSidebar, PlanComposer, PlanWorkspace,
PlanSectionCard; Plan types + API client (incl. mock mode); planning
i18n block; nav links from landing and /research; component tests for
the section card and the SSE reducer.
</commit_message>
<xml_diff>
--- a/docs/CaseLogic_7min_Presentation.pptx
+++ b/docs/CaseLogic_7min_Presentation.pptx
@@ -8,7 +8,7 @@
     <p:notesMasterId r:id="rId11"/>
   </p:notesMasterIdLst>
   <p:sldIdLst>
-    <p:sldId id="256" r:id="rId2"/>
+    <p:sldId id="265" r:id="rId2"/>
     <p:sldId id="257" r:id="rId3"/>
     <p:sldId id="258" r:id="rId4"/>
     <p:sldId id="259" r:id="rId5"/>
@@ -115,6 +115,11 @@
       </a:defRPr>
     </a:lvl9pPr>
   </p:defaultTextStyle>
+  <p:extLst>
+    <p:ext uri="{EFAFB233-063F-42B5-8137-9DF3F51BA10A}">
+      <p15:sldGuideLst xmlns:p15="http://schemas.microsoft.com/office/powerpoint/2012/main"/>
+    </p:ext>
+  </p:extLst>
 </p:presentation>
 </file>
 
@@ -512,16 +517,45 @@
           <a:bodyPr/>
           <a:lstStyle/>
           <a:p>
-            <a:r>
-              <a:rPr lang="en-US" smtClean="0">
+            <a:pPr marL="0" marR="0" indent="0" algn="l" defTabSz="914400" rtl="0" eaLnBrk="1" fontAlgn="auto" latinLnBrk="0" hangingPunct="1">
+              <a:lnSpc>
+                <a:spcPct val="100000"/>
+              </a:lnSpc>
+              <a:spcBef>
+                <a:spcPts val="0"/>
+              </a:spcBef>
+              <a:spcAft>
+                <a:spcPts val="0"/>
+              </a:spcAft>
+              <a:buClrTx/>
+              <a:buSzTx/>
+              <a:buFontTx/>
+              <a:buNone/>
+              <a:tabLst/>
+              <a:defRPr/>
+            </a:pPr>
+            <a:r>
+              <a:rPr lang="en-US" dirty="0" smtClean="0">
                 <a:latin typeface="Aptos"/>
               </a:rPr>
               <a:t>0:00-0:40
 Open by framing this as an implementation review, not a speculative roadmap.
-The story: CaseLogic is trying to make vehicle-law research trustworthy by forcing retrieval before answer generation.
-Call out the three themes on screen: hybrid retrieval, grounded chat, inspectable sources.</a:t>
-            </a:r>
-            <a:endParaRPr lang="en-US">
+The story: </a:t>
+            </a:r>
+            <a:r>
+              <a:rPr lang="en-US" dirty="0" err="1" smtClean="0">
+                <a:latin typeface="Aptos"/>
+              </a:rPr>
+              <a:t>CaseLogic</a:t>
+            </a:r>
+            <a:r>
+              <a:rPr lang="en-US" dirty="0" smtClean="0">
+                <a:latin typeface="Aptos"/>
+              </a:rPr>
+              <a:t> is trying to make vehicle-law research trustworthy by forcing retrieval before answer generation.
+Call out the three themes on screen: hybrid retrieval, </a:t>
+            </a:r>
+            <a:endParaRPr lang="en-US" dirty="0">
               <a:latin typeface="Aptos"/>
             </a:endParaRPr>
           </a:p>
@@ -553,7 +587,7 @@
     </p:spTree>
     <p:extLst>
       <p:ext uri="{BB962C8B-B14F-4D97-AF65-F5344CB8AC3E}">
-        <p14:creationId xmlns:p14="http://schemas.microsoft.com/office/powerpoint/2010/main" val="2053286643"/>
+        <p14:creationId xmlns:p14="http://schemas.microsoft.com/office/powerpoint/2010/main" val="1008347166"/>
       </p:ext>
     </p:extLst>
   </p:cSld>
@@ -4306,46 +4340,6 @@
       </p:sp>
       <p:sp>
         <p:nvSpPr>
-          <p:cNvPr id="4" name="TextBox 3"/>
-          <p:cNvSpPr txBox="1"/>
-          <p:nvPr/>
-        </p:nvSpPr>
-        <p:spPr>
-          <a:xfrm>
-            <a:off x="558800" y="584200"/>
-            <a:ext cx="3302000" cy="271869"/>
-          </a:xfrm>
-          <a:prstGeom prst="rect">
-            <a:avLst/>
-          </a:prstGeom>
-          <a:noFill/>
-        </p:spPr>
-        <p:txBody>
-          <a:bodyPr vert="horz" wrap="square" lIns="101600" tIns="50800" rIns="101600" bIns="50800" rtlCol="0">
-            <a:spAutoFit/>
-          </a:bodyPr>
-          <a:lstStyle/>
-          <a:p>
-            <a:r>
-              <a:rPr lang="en-US" sz="1100" b="1" smtClean="0">
-                <a:solidFill>
-                  <a:srgbClr val="94A3B8"/>
-                </a:solidFill>
-                <a:latin typeface="Aptos"/>
-              </a:rPr>
-              <a:t>7-MINUTE IMPLEMENTATION REVIEW</a:t>
-            </a:r>
-            <a:endParaRPr lang="en-US" sz="1100" b="1">
-              <a:solidFill>
-                <a:srgbClr val="94A3B8"/>
-              </a:solidFill>
-              <a:latin typeface="Aptos"/>
-            </a:endParaRPr>
-          </a:p>
-        </p:txBody>
-      </p:sp>
-      <p:sp>
-        <p:nvSpPr>
           <p:cNvPr id="5" name="TextBox 4"/>
           <p:cNvSpPr txBox="1"/>
           <p:nvPr/>
@@ -4465,64 +4459,24 @@
       </p:sp>
       <p:sp>
         <p:nvSpPr>
-          <p:cNvPr id="8" name="TextBox 7"/>
-          <p:cNvSpPr txBox="1"/>
-          <p:nvPr/>
-        </p:nvSpPr>
-        <p:spPr>
-          <a:xfrm>
-            <a:off x="558800" y="3429000"/>
-            <a:ext cx="6604000" cy="564257"/>
-          </a:xfrm>
-          <a:prstGeom prst="rect">
-            <a:avLst/>
-          </a:prstGeom>
-          <a:noFill/>
-        </p:spPr>
-        <p:txBody>
-          <a:bodyPr vert="horz" wrap="square" lIns="101600" tIns="50800" rIns="101600" bIns="50800" rtlCol="0">
-            <a:spAutoFit/>
-          </a:bodyPr>
-          <a:lstStyle/>
-          <a:p>
-            <a:r>
-              <a:rPr lang="en-US" sz="1500" smtClean="0">
-                <a:solidFill>
-                  <a:srgbClr val="94A3B8"/>
-                </a:solidFill>
-                <a:latin typeface="Aptos"/>
-              </a:rPr>
-              <a:t>This deck is based on the implemented code paths, passing smoke tests, and the repo walkthrough -- not on unfinished roadmap claims.</a:t>
-            </a:r>
-            <a:endParaRPr lang="en-US" sz="1500">
-              <a:solidFill>
-                <a:srgbClr val="94A3B8"/>
-              </a:solidFill>
-              <a:latin typeface="Aptos"/>
-            </a:endParaRPr>
-          </a:p>
-        </p:txBody>
-      </p:sp>
-      <p:sp>
-        <p:nvSpPr>
-          <p:cNvPr id="9" name="Rounded Rectangle 8"/>
+          <p:cNvPr id="15" name="Rounded Rectangle 14"/>
           <p:cNvSpPr/>
           <p:nvPr/>
         </p:nvSpPr>
         <p:spPr>
           <a:xfrm>
-            <a:off x="558800" y="4826000"/>
-            <a:ext cx="2159000" cy="533400"/>
+            <a:off x="7874000" y="1955800"/>
+            <a:ext cx="3683000" cy="3556000"/>
           </a:xfrm>
           <a:prstGeom prst="roundRect">
             <a:avLst/>
           </a:prstGeom>
           <a:solidFill>
-            <a:srgbClr val="1E293B"/>
+            <a:srgbClr val="121E36"/>
           </a:solidFill>
-          <a:ln w="12700" cap="flat" cmpd="sng" algn="ctr">
+          <a:ln w="19050" cap="flat" cmpd="sng" algn="ctr">
             <a:solidFill>
-              <a:srgbClr val="475569"/>
+              <a:srgbClr val="2DD4BF"/>
             </a:solidFill>
             <a:prstDash val="solid"/>
             <a:miter lim="800000"/>
@@ -4557,14 +4511,14 @@
       </p:sp>
       <p:sp>
         <p:nvSpPr>
-          <p:cNvPr id="10" name="TextBox 9"/>
+          <p:cNvPr id="16" name="TextBox 15"/>
           <p:cNvSpPr txBox="1"/>
           <p:nvPr/>
         </p:nvSpPr>
         <p:spPr>
           <a:xfrm>
-            <a:off x="660400" y="4940300"/>
-            <a:ext cx="1955800" cy="318036"/>
+            <a:off x="8178800" y="2260600"/>
+            <a:ext cx="3048000" cy="379591"/>
           </a:xfrm>
           <a:prstGeom prst="rect">
             <a:avLst/>
@@ -4578,32 +4532,110 @@
           <a:lstStyle/>
           <a:p>
             <a:r>
-              <a:rPr lang="en-US" sz="1400" b="1" smtClean="0">
+              <a:rPr lang="en-US" b="1" smtClean="0">
                 <a:solidFill>
                   <a:srgbClr val="F8FAFC"/>
                 </a:solidFill>
-                <a:latin typeface="Aptos"/>
+                <a:latin typeface="Aptos Display"/>
               </a:rPr>
-              <a:t>Hybrid retrieval</a:t>
-            </a:r>
-            <a:endParaRPr lang="en-US" sz="1400" b="1">
+              <a:t>Implemented anchors</a:t>
+            </a:r>
+            <a:endParaRPr lang="en-US" b="1">
               <a:solidFill>
                 <a:srgbClr val="F8FAFC"/>
               </a:solidFill>
+              <a:latin typeface="Aptos Display"/>
+            </a:endParaRPr>
+          </a:p>
+        </p:txBody>
+      </p:sp>
+      <p:sp>
+        <p:nvSpPr>
+          <p:cNvPr id="17" name="TextBox 16"/>
+          <p:cNvSpPr txBox="1"/>
+          <p:nvPr/>
+        </p:nvSpPr>
+        <p:spPr>
+          <a:xfrm>
+            <a:off x="8178800" y="2794000"/>
+            <a:ext cx="3048000" cy="2041585"/>
+          </a:xfrm>
+          <a:prstGeom prst="rect">
+            <a:avLst/>
+          </a:prstGeom>
+          <a:noFill/>
+        </p:spPr>
+        <p:txBody>
+          <a:bodyPr vert="horz" wrap="square" lIns="101600" tIns="50800" rIns="101600" bIns="50800" rtlCol="0">
+            <a:spAutoFit/>
+          </a:bodyPr>
+          <a:lstStyle/>
+          <a:p>
+            <a:r>
+              <a:rPr lang="en-US" sz="1400" dirty="0" smtClean="0">
+                <a:solidFill>
+                  <a:srgbClr val="CBD5E1"/>
+                </a:solidFill>
+                <a:latin typeface="Aptos"/>
+              </a:rPr>
+              <a:t>backend/main.py mounts status, ingest, statutes, chat, and chats.</a:t>
+            </a:r>
+          </a:p>
+          <a:p>
+            <a:endParaRPr lang="en-US" sz="1400" dirty="0" smtClean="0">
+              <a:solidFill>
+                <a:srgbClr val="CBD5E1"/>
+              </a:solidFill>
               <a:latin typeface="Aptos"/>
             </a:endParaRPr>
           </a:p>
-        </p:txBody>
-      </p:sp>
-      <p:sp>
-        <p:nvSpPr>
-          <p:cNvPr id="11" name="Rounded Rectangle 10"/>
+          <a:p>
+            <a:r>
+              <a:rPr lang="en-US" sz="1400" dirty="0" smtClean="0">
+                <a:solidFill>
+                  <a:srgbClr val="CBD5E1"/>
+                </a:solidFill>
+                <a:latin typeface="Aptos"/>
+              </a:rPr>
+              <a:t>Hybrid retrieval combines citation parsing, FTS5, Chroma, and RRF.</a:t>
+            </a:r>
+          </a:p>
+          <a:p>
+            <a:endParaRPr lang="en-US" sz="1400" dirty="0" smtClean="0">
+              <a:solidFill>
+                <a:srgbClr val="CBD5E1"/>
+              </a:solidFill>
+              <a:latin typeface="Aptos"/>
+            </a:endParaRPr>
+          </a:p>
+          <a:p>
+            <a:r>
+              <a:rPr lang="en-US" sz="1400" dirty="0" smtClean="0">
+                <a:solidFill>
+                  <a:srgbClr val="CBD5E1"/>
+                </a:solidFill>
+                <a:latin typeface="Aptos"/>
+              </a:rPr>
+              <a:t>The frontend now uses a persistent chat workflow with inline statute cards and a source modal.</a:t>
+            </a:r>
+            <a:endParaRPr lang="en-US" sz="1400" dirty="0">
+              <a:solidFill>
+                <a:srgbClr val="CBD5E1"/>
+              </a:solidFill>
+              <a:latin typeface="Aptos"/>
+            </a:endParaRPr>
+          </a:p>
+        </p:txBody>
+      </p:sp>
+      <p:sp>
+        <p:nvSpPr>
+          <p:cNvPr id="22" name="Rounded Rectangle 21"/>
           <p:cNvSpPr/>
           <p:nvPr/>
         </p:nvSpPr>
         <p:spPr>
           <a:xfrm>
-            <a:off x="2870200" y="4826000"/>
+            <a:off x="558800" y="5825241"/>
             <a:ext cx="2159000" cy="533400"/>
           </a:xfrm>
           <a:prstGeom prst="roundRect">
@@ -4649,14 +4681,14 @@
       </p:sp>
       <p:sp>
         <p:nvSpPr>
-          <p:cNvPr id="12" name="TextBox 11"/>
+          <p:cNvPr id="23" name="TextBox 22"/>
           <p:cNvSpPr txBox="1"/>
           <p:nvPr/>
         </p:nvSpPr>
         <p:spPr>
           <a:xfrm>
-            <a:off x="2971800" y="4940300"/>
-            <a:ext cx="1955800" cy="533479"/>
+            <a:off x="660400" y="5939541"/>
+            <a:ext cx="1955800" cy="318036"/>
           </a:xfrm>
           <a:prstGeom prst="rect">
             <a:avLst/>
@@ -4670,15 +4702,15 @@
           <a:lstStyle/>
           <a:p>
             <a:r>
-              <a:rPr lang="en-US" sz="1400" b="1" smtClean="0">
+              <a:rPr lang="en-US" sz="1400" b="1" dirty="0" smtClean="0">
                 <a:solidFill>
                   <a:srgbClr val="F8FAFC"/>
                 </a:solidFill>
                 <a:latin typeface="Aptos"/>
               </a:rPr>
-              <a:t>Grounded chat agent</a:t>
-            </a:r>
-            <a:endParaRPr lang="en-US" sz="1400" b="1">
+              <a:t>Danial</a:t>
+            </a:r>
+            <a:endParaRPr lang="en-US" sz="1400" b="1" dirty="0">
               <a:solidFill>
                 <a:srgbClr val="F8FAFC"/>
               </a:solidFill>
@@ -4689,13 +4721,13 @@
       </p:sp>
       <p:sp>
         <p:nvSpPr>
-          <p:cNvPr id="13" name="Rounded Rectangle 12"/>
+          <p:cNvPr id="24" name="Rounded Rectangle 23"/>
           <p:cNvSpPr/>
           <p:nvPr/>
         </p:nvSpPr>
         <p:spPr>
           <a:xfrm>
-            <a:off x="5181600" y="4826000"/>
+            <a:off x="2870200" y="5825241"/>
             <a:ext cx="2159000" cy="533400"/>
           </a:xfrm>
           <a:prstGeom prst="roundRect">
@@ -4741,13 +4773,13 @@
       </p:sp>
       <p:sp>
         <p:nvSpPr>
-          <p:cNvPr id="14" name="TextBox 13"/>
+          <p:cNvPr id="25" name="TextBox 24"/>
           <p:cNvSpPr txBox="1"/>
           <p:nvPr/>
         </p:nvSpPr>
         <p:spPr>
           <a:xfrm>
-            <a:off x="5283200" y="4940300"/>
+            <a:off x="2971800" y="5939541"/>
             <a:ext cx="1955800" cy="318036"/>
           </a:xfrm>
           <a:prstGeom prst="rect">
@@ -4762,15 +4794,15 @@
           <a:lstStyle/>
           <a:p>
             <a:r>
-              <a:rPr lang="en-US" sz="1400" b="1" smtClean="0">
+              <a:rPr lang="en-US" sz="1400" b="1" dirty="0" err="1" smtClean="0">
                 <a:solidFill>
                   <a:srgbClr val="F8FAFC"/>
                 </a:solidFill>
                 <a:latin typeface="Aptos"/>
               </a:rPr>
-              <a:t>Inspectable sources</a:t>
-            </a:r>
-            <a:endParaRPr lang="en-US" sz="1400" b="1">
+              <a:t>Alireza</a:t>
+            </a:r>
+            <a:endParaRPr lang="en-US" sz="1400" b="1" dirty="0">
               <a:solidFill>
                 <a:srgbClr val="F8FAFC"/>
               </a:solidFill>
@@ -4781,24 +4813,24 @@
       </p:sp>
       <p:sp>
         <p:nvSpPr>
-          <p:cNvPr id="15" name="Rounded Rectangle 14"/>
+          <p:cNvPr id="26" name="Rounded Rectangle 25"/>
           <p:cNvSpPr/>
           <p:nvPr/>
         </p:nvSpPr>
         <p:spPr>
           <a:xfrm>
-            <a:off x="7874000" y="1955800"/>
-            <a:ext cx="3683000" cy="3556000"/>
+            <a:off x="5181600" y="5825241"/>
+            <a:ext cx="2159000" cy="533400"/>
           </a:xfrm>
           <a:prstGeom prst="roundRect">
             <a:avLst/>
           </a:prstGeom>
           <a:solidFill>
-            <a:srgbClr val="121E36"/>
+            <a:srgbClr val="1E293B"/>
           </a:solidFill>
-          <a:ln w="19050" cap="flat" cmpd="sng" algn="ctr">
+          <a:ln w="12700" cap="flat" cmpd="sng" algn="ctr">
             <a:solidFill>
-              <a:srgbClr val="2DD4BF"/>
+              <a:srgbClr val="475569"/>
             </a:solidFill>
             <a:prstDash val="solid"/>
             <a:miter lim="800000"/>
@@ -4833,14 +4865,14 @@
       </p:sp>
       <p:sp>
         <p:nvSpPr>
-          <p:cNvPr id="16" name="TextBox 15"/>
+          <p:cNvPr id="27" name="TextBox 26"/>
           <p:cNvSpPr txBox="1"/>
           <p:nvPr/>
         </p:nvSpPr>
         <p:spPr>
           <a:xfrm>
-            <a:off x="8178800" y="2260600"/>
-            <a:ext cx="3048000" cy="379591"/>
+            <a:off x="5283200" y="5939541"/>
+            <a:ext cx="1955800" cy="318036"/>
           </a:xfrm>
           <a:prstGeom prst="rect">
             <a:avLst/>
@@ -4854,33 +4886,85 @@
           <a:lstStyle/>
           <a:p>
             <a:r>
-              <a:rPr lang="en-US" b="1" smtClean="0">
+              <a:rPr lang="en-US" sz="1400" b="1" dirty="0" smtClean="0">
                 <a:solidFill>
                   <a:srgbClr val="F8FAFC"/>
                 </a:solidFill>
-                <a:latin typeface="Aptos Display"/>
+                <a:latin typeface="Aptos"/>
               </a:rPr>
-              <a:t>Implemented anchors</a:t>
-            </a:r>
-            <a:endParaRPr lang="en-US" b="1">
+              <a:t>Amin</a:t>
+            </a:r>
+            <a:endParaRPr lang="en-US" sz="1400" b="1" dirty="0">
               <a:solidFill>
                 <a:srgbClr val="F8FAFC"/>
               </a:solidFill>
-              <a:latin typeface="Aptos Display"/>
+              <a:latin typeface="Aptos"/>
             </a:endParaRPr>
           </a:p>
         </p:txBody>
       </p:sp>
       <p:sp>
         <p:nvSpPr>
-          <p:cNvPr id="17" name="TextBox 16"/>
+          <p:cNvPr id="28" name="Rounded Rectangle 27"/>
+          <p:cNvSpPr/>
+          <p:nvPr/>
+        </p:nvSpPr>
+        <p:spPr>
+          <a:xfrm>
+            <a:off x="7493000" y="5825241"/>
+            <a:ext cx="2159000" cy="533400"/>
+          </a:xfrm>
+          <a:prstGeom prst="roundRect">
+            <a:avLst/>
+          </a:prstGeom>
+          <a:solidFill>
+            <a:srgbClr val="1E293B"/>
+          </a:solidFill>
+          <a:ln w="12700" cap="flat" cmpd="sng" algn="ctr">
+            <a:solidFill>
+              <a:srgbClr val="475569"/>
+            </a:solidFill>
+            <a:prstDash val="solid"/>
+            <a:miter lim="800000"/>
+            <a:headEnd type="none" w="med" len="med"/>
+            <a:tailEnd type="none" w="med" len="med"/>
+          </a:ln>
+        </p:spPr>
+        <p:style>
+          <a:lnRef idx="2">
+            <a:schemeClr val="accent1">
+              <a:shade val="50000"/>
+            </a:schemeClr>
+          </a:lnRef>
+          <a:fillRef idx="1">
+            <a:schemeClr val="accent1"/>
+          </a:fillRef>
+          <a:effectRef idx="0">
+            <a:schemeClr val="accent1"/>
+          </a:effectRef>
+          <a:fontRef idx="minor">
+            <a:schemeClr val="lt1"/>
+          </a:fontRef>
+        </p:style>
+        <p:txBody>
+          <a:bodyPr rtlCol="0" anchor="ctr"/>
+          <a:lstStyle/>
+          <a:p>
+            <a:pPr algn="ctr"/>
+            <a:endParaRPr lang="en-US"/>
+          </a:p>
+        </p:txBody>
+      </p:sp>
+      <p:sp>
+        <p:nvSpPr>
+          <p:cNvPr id="29" name="TextBox 28"/>
           <p:cNvSpPr txBox="1"/>
           <p:nvPr/>
         </p:nvSpPr>
         <p:spPr>
           <a:xfrm>
-            <a:off x="8178800" y="2794000"/>
-            <a:ext cx="3048000" cy="2041585"/>
+            <a:off x="7594600" y="5939541"/>
+            <a:ext cx="1955800" cy="318036"/>
           </a:xfrm>
           <a:prstGeom prst="rect">
             <a:avLst/>
@@ -4894,65 +4978,119 @@
           <a:lstStyle/>
           <a:p>
             <a:r>
-              <a:rPr lang="en-US" sz="1400" smtClean="0">
+              <a:rPr lang="en-US" sz="1400" b="1" dirty="0" err="1" smtClean="0">
                 <a:solidFill>
-                  <a:srgbClr val="CBD5E1"/>
+                  <a:srgbClr val="F8FAFC"/>
                 </a:solidFill>
                 <a:latin typeface="Aptos"/>
               </a:rPr>
-              <a:t>backend/main.py mounts status, ingest, statutes, chat, and chats.</a:t>
-            </a:r>
-          </a:p>
-          <a:p>
-            <a:endParaRPr lang="en-US" sz="1400" smtClean="0">
+              <a:t>Liyu</a:t>
+            </a:r>
+            <a:endParaRPr lang="en-US" sz="1400" b="1" dirty="0">
               <a:solidFill>
-                <a:srgbClr val="CBD5E1"/>
+                <a:srgbClr val="F8FAFC"/>
               </a:solidFill>
               <a:latin typeface="Aptos"/>
             </a:endParaRPr>
           </a:p>
-          <a:p>
-            <a:r>
-              <a:rPr lang="en-US" sz="1400" smtClean="0">
+        </p:txBody>
+      </p:sp>
+      <p:sp>
+        <p:nvSpPr>
+          <p:cNvPr id="30" name="Rounded Rectangle 29"/>
+          <p:cNvSpPr/>
+          <p:nvPr/>
+        </p:nvSpPr>
+        <p:spPr>
+          <a:xfrm>
+            <a:off x="9804400" y="5834281"/>
+            <a:ext cx="2159000" cy="533400"/>
+          </a:xfrm>
+          <a:prstGeom prst="roundRect">
+            <a:avLst/>
+          </a:prstGeom>
+          <a:solidFill>
+            <a:srgbClr val="1E293B"/>
+          </a:solidFill>
+          <a:ln w="12700" cap="flat" cmpd="sng" algn="ctr">
+            <a:solidFill>
+              <a:srgbClr val="475569"/>
+            </a:solidFill>
+            <a:prstDash val="solid"/>
+            <a:miter lim="800000"/>
+            <a:headEnd type="none" w="med" len="med"/>
+            <a:tailEnd type="none" w="med" len="med"/>
+          </a:ln>
+        </p:spPr>
+        <p:style>
+          <a:lnRef idx="2">
+            <a:schemeClr val="accent1">
+              <a:shade val="50000"/>
+            </a:schemeClr>
+          </a:lnRef>
+          <a:fillRef idx="1">
+            <a:schemeClr val="accent1"/>
+          </a:fillRef>
+          <a:effectRef idx="0">
+            <a:schemeClr val="accent1"/>
+          </a:effectRef>
+          <a:fontRef idx="minor">
+            <a:schemeClr val="lt1"/>
+          </a:fontRef>
+        </p:style>
+        <p:txBody>
+          <a:bodyPr rtlCol="0" anchor="ctr"/>
+          <a:lstStyle/>
+          <a:p>
+            <a:pPr algn="ctr"/>
+            <a:endParaRPr lang="en-US"/>
+          </a:p>
+        </p:txBody>
+      </p:sp>
+      <p:sp>
+        <p:nvSpPr>
+          <p:cNvPr id="31" name="TextBox 30"/>
+          <p:cNvSpPr txBox="1"/>
+          <p:nvPr/>
+        </p:nvSpPr>
+        <p:spPr>
+          <a:xfrm>
+            <a:off x="9906000" y="5948581"/>
+            <a:ext cx="1955800" cy="318036"/>
+          </a:xfrm>
+          <a:prstGeom prst="rect">
+            <a:avLst/>
+          </a:prstGeom>
+          <a:noFill/>
+        </p:spPr>
+        <p:txBody>
+          <a:bodyPr vert="horz" wrap="square" lIns="101600" tIns="50800" rIns="101600" bIns="50800" rtlCol="0">
+            <a:spAutoFit/>
+          </a:bodyPr>
+          <a:lstStyle/>
+          <a:p>
+            <a:r>
+              <a:rPr lang="en-US" sz="1400" b="1" dirty="0" err="1" smtClean="0">
                 <a:solidFill>
-                  <a:srgbClr val="CBD5E1"/>
+                  <a:srgbClr val="F8FAFC"/>
                 </a:solidFill>
                 <a:latin typeface="Aptos"/>
               </a:rPr>
-              <a:t>Hybrid retrieval combines citation parsing, FTS5, Chroma, and RRF.</a:t>
-            </a:r>
-          </a:p>
-          <a:p>
-            <a:endParaRPr lang="en-US" sz="1400" smtClean="0">
+              <a:t>Bipon</a:t>
+            </a:r>
+            <a:endParaRPr lang="en-US" sz="1400" b="1" dirty="0">
               <a:solidFill>
-                <a:srgbClr val="CBD5E1"/>
+                <a:srgbClr val="F8FAFC"/>
               </a:solidFill>
               <a:latin typeface="Aptos"/>
             </a:endParaRPr>
           </a:p>
-          <a:p>
-            <a:r>
-              <a:rPr lang="en-US" sz="1400" smtClean="0">
-                <a:solidFill>
-                  <a:srgbClr val="CBD5E1"/>
-                </a:solidFill>
-                <a:latin typeface="Aptos"/>
-              </a:rPr>
-              <a:t>The frontend now uses a persistent chat workflow with inline statute cards and a source modal.</a:t>
-            </a:r>
-            <a:endParaRPr lang="en-US" sz="1400">
-              <a:solidFill>
-                <a:srgbClr val="CBD5E1"/>
-              </a:solidFill>
-              <a:latin typeface="Aptos"/>
-            </a:endParaRPr>
-          </a:p>
         </p:txBody>
       </p:sp>
     </p:spTree>
     <p:extLst>
       <p:ext uri="{BB962C8B-B14F-4D97-AF65-F5344CB8AC3E}">
-        <p14:creationId xmlns:p14="http://schemas.microsoft.com/office/powerpoint/2010/main" val="4167623871"/>
+        <p14:creationId xmlns:p14="http://schemas.microsoft.com/office/powerpoint/2010/main" val="4008931707"/>
       </p:ext>
     </p:extLst>
   </p:cSld>
@@ -5038,7 +5176,61 @@
                                           </p:stCondLst>
                                         </p:cTn>
                                         <p:tgtEl>
-                                          <p:spTgt spid="8"/>
+                                          <p:spTgt spid="15"/>
+                                        </p:tgtEl>
+                                        <p:attrNameLst>
+                                          <p:attrName>style.visibility</p:attrName>
+                                        </p:attrNameLst>
+                                      </p:cBhvr>
+                                      <p:to>
+                                        <p:strVal val="visible"/>
+                                      </p:to>
+                                    </p:set>
+                                  </p:childTnLst>
+                                </p:cTn>
+                              </p:par>
+                              <p:par>
+                                <p:cTn id="11" presetID="1" presetClass="entr" presetSubtype="0" fill="hold" grpId="0" nodeType="withEffect">
+                                  <p:stCondLst>
+                                    <p:cond delay="0"/>
+                                  </p:stCondLst>
+                                  <p:childTnLst>
+                                    <p:set>
+                                      <p:cBhvr>
+                                        <p:cTn id="12" dur="1" fill="hold">
+                                          <p:stCondLst>
+                                            <p:cond delay="0"/>
+                                          </p:stCondLst>
+                                        </p:cTn>
+                                        <p:tgtEl>
+                                          <p:spTgt spid="16"/>
+                                        </p:tgtEl>
+                                        <p:attrNameLst>
+                                          <p:attrName>style.visibility</p:attrName>
+                                        </p:attrNameLst>
+                                      </p:cBhvr>
+                                      <p:to>
+                                        <p:strVal val="visible"/>
+                                      </p:to>
+                                    </p:set>
+                                  </p:childTnLst>
+                                </p:cTn>
+                              </p:par>
+                              <p:par>
+                                <p:cTn id="13" presetID="1" presetClass="entr" presetSubtype="0" fill="hold" grpId="0" nodeType="withEffect">
+                                  <p:stCondLst>
+                                    <p:cond delay="0"/>
+                                  </p:stCondLst>
+                                  <p:childTnLst>
+                                    <p:set>
+                                      <p:cBhvr>
+                                        <p:cTn id="14" dur="1" fill="hold">
+                                          <p:stCondLst>
+                                            <p:cond delay="0"/>
+                                          </p:stCondLst>
+                                        </p:cTn>
+                                        <p:tgtEl>
+                                          <p:spTgt spid="17"/>
                                         </p:tgtEl>
                                         <p:attrNameLst>
                                           <p:attrName>style.visibility</p:attrName>
@@ -5058,32 +5250,32 @@
                     </p:cTn>
                   </p:par>
                   <p:par>
-                    <p:cTn id="11" fill="hold">
+                    <p:cTn id="15" fill="hold">
                       <p:stCondLst>
                         <p:cond delay="indefinite"/>
                       </p:stCondLst>
                       <p:childTnLst>
                         <p:par>
-                          <p:cTn id="12" fill="hold">
+                          <p:cTn id="16" fill="hold">
                             <p:stCondLst>
                               <p:cond delay="0"/>
                             </p:stCondLst>
                             <p:childTnLst>
                               <p:par>
-                                <p:cTn id="13" presetID="1" presetClass="entr" presetSubtype="0" fill="hold" grpId="0" nodeType="clickEffect">
+                                <p:cTn id="17" presetID="1" presetClass="entr" presetSubtype="0" fill="hold" grpId="0" nodeType="clickEffect">
                                   <p:stCondLst>
                                     <p:cond delay="0"/>
                                   </p:stCondLst>
                                   <p:childTnLst>
                                     <p:set>
                                       <p:cBhvr>
-                                        <p:cTn id="14" dur="1" fill="hold">
+                                        <p:cTn id="18" dur="1" fill="hold">
                                           <p:stCondLst>
                                             <p:cond delay="0"/>
                                           </p:stCondLst>
                                         </p:cTn>
                                         <p:tgtEl>
-                                          <p:spTgt spid="9"/>
+                                          <p:spTgt spid="22"/>
                                         </p:tgtEl>
                                         <p:attrNameLst>
                                           <p:attrName>style.visibility</p:attrName>
@@ -5097,20 +5289,20 @@
                                 </p:cTn>
                               </p:par>
                               <p:par>
-                                <p:cTn id="15" presetID="1" presetClass="entr" presetSubtype="0" fill="hold" grpId="0" nodeType="withEffect">
+                                <p:cTn id="19" presetID="1" presetClass="entr" presetSubtype="0" fill="hold" grpId="0" nodeType="withEffect">
                                   <p:stCondLst>
                                     <p:cond delay="0"/>
                                   </p:stCondLst>
                                   <p:childTnLst>
                                     <p:set>
                                       <p:cBhvr>
-                                        <p:cTn id="16" dur="1" fill="hold">
+                                        <p:cTn id="20" dur="1" fill="hold">
                                           <p:stCondLst>
                                             <p:cond delay="0"/>
                                           </p:stCondLst>
                                         </p:cTn>
                                         <p:tgtEl>
-                                          <p:spTgt spid="10"/>
+                                          <p:spTgt spid="23"/>
                                         </p:tgtEl>
                                         <p:attrNameLst>
                                           <p:attrName>style.visibility</p:attrName>
@@ -5130,32 +5322,32 @@
                     </p:cTn>
                   </p:par>
                   <p:par>
-                    <p:cTn id="17" fill="hold">
+                    <p:cTn id="21" fill="hold">
                       <p:stCondLst>
                         <p:cond delay="indefinite"/>
                       </p:stCondLst>
                       <p:childTnLst>
                         <p:par>
-                          <p:cTn id="18" fill="hold">
+                          <p:cTn id="22" fill="hold">
                             <p:stCondLst>
                               <p:cond delay="0"/>
                             </p:stCondLst>
                             <p:childTnLst>
                               <p:par>
-                                <p:cTn id="19" presetID="1" presetClass="entr" presetSubtype="0" fill="hold" grpId="0" nodeType="clickEffect">
+                                <p:cTn id="23" presetID="1" presetClass="entr" presetSubtype="0" fill="hold" grpId="0" nodeType="clickEffect">
                                   <p:stCondLst>
                                     <p:cond delay="0"/>
                                   </p:stCondLst>
                                   <p:childTnLst>
                                     <p:set>
                                       <p:cBhvr>
-                                        <p:cTn id="20" dur="1" fill="hold">
+                                        <p:cTn id="24" dur="1" fill="hold">
                                           <p:stCondLst>
                                             <p:cond delay="0"/>
                                           </p:stCondLst>
                                         </p:cTn>
                                         <p:tgtEl>
-                                          <p:spTgt spid="11"/>
+                                          <p:spTgt spid="24"/>
                                         </p:tgtEl>
                                         <p:attrNameLst>
                                           <p:attrName>style.visibility</p:attrName>
@@ -5169,20 +5361,20 @@
                                 </p:cTn>
                               </p:par>
                               <p:par>
-                                <p:cTn id="21" presetID="1" presetClass="entr" presetSubtype="0" fill="hold" grpId="0" nodeType="withEffect">
+                                <p:cTn id="25" presetID="1" presetClass="entr" presetSubtype="0" fill="hold" grpId="0" nodeType="withEffect">
                                   <p:stCondLst>
                                     <p:cond delay="0"/>
                                   </p:stCondLst>
                                   <p:childTnLst>
                                     <p:set>
                                       <p:cBhvr>
-                                        <p:cTn id="22" dur="1" fill="hold">
+                                        <p:cTn id="26" dur="1" fill="hold">
                                           <p:stCondLst>
                                             <p:cond delay="0"/>
                                           </p:stCondLst>
                                         </p:cTn>
                                         <p:tgtEl>
-                                          <p:spTgt spid="12"/>
+                                          <p:spTgt spid="25"/>
                                         </p:tgtEl>
                                         <p:attrNameLst>
                                           <p:attrName>style.visibility</p:attrName>
@@ -5202,32 +5394,32 @@
                     </p:cTn>
                   </p:par>
                   <p:par>
-                    <p:cTn id="23" fill="hold">
+                    <p:cTn id="27" fill="hold">
                       <p:stCondLst>
                         <p:cond delay="indefinite"/>
                       </p:stCondLst>
                       <p:childTnLst>
                         <p:par>
-                          <p:cTn id="24" fill="hold">
+                          <p:cTn id="28" fill="hold">
                             <p:stCondLst>
                               <p:cond delay="0"/>
                             </p:stCondLst>
                             <p:childTnLst>
                               <p:par>
-                                <p:cTn id="25" presetID="1" presetClass="entr" presetSubtype="0" fill="hold" grpId="0" nodeType="clickEffect">
+                                <p:cTn id="29" presetID="1" presetClass="entr" presetSubtype="0" fill="hold" grpId="0" nodeType="clickEffect">
                                   <p:stCondLst>
                                     <p:cond delay="0"/>
                                   </p:stCondLst>
                                   <p:childTnLst>
                                     <p:set>
                                       <p:cBhvr>
-                                        <p:cTn id="26" dur="1" fill="hold">
+                                        <p:cTn id="30" dur="1" fill="hold">
                                           <p:stCondLst>
                                             <p:cond delay="0"/>
                                           </p:stCondLst>
                                         </p:cTn>
                                         <p:tgtEl>
-                                          <p:spTgt spid="13"/>
+                                          <p:spTgt spid="26"/>
                                         </p:tgtEl>
                                         <p:attrNameLst>
                                           <p:attrName>style.visibility</p:attrName>
@@ -5241,20 +5433,20 @@
                                 </p:cTn>
                               </p:par>
                               <p:par>
-                                <p:cTn id="27" presetID="1" presetClass="entr" presetSubtype="0" fill="hold" grpId="0" nodeType="withEffect">
+                                <p:cTn id="31" presetID="1" presetClass="entr" presetSubtype="0" fill="hold" grpId="0" nodeType="withEffect">
                                   <p:stCondLst>
                                     <p:cond delay="0"/>
                                   </p:stCondLst>
                                   <p:childTnLst>
                                     <p:set>
                                       <p:cBhvr>
-                                        <p:cTn id="28" dur="1" fill="hold">
+                                        <p:cTn id="32" dur="1" fill="hold">
                                           <p:stCondLst>
                                             <p:cond delay="0"/>
                                           </p:stCondLst>
                                         </p:cTn>
                                         <p:tgtEl>
-                                          <p:spTgt spid="14"/>
+                                          <p:spTgt spid="27"/>
                                         </p:tgtEl>
                                         <p:attrNameLst>
                                           <p:attrName>style.visibility</p:attrName>
@@ -5274,32 +5466,32 @@
                     </p:cTn>
                   </p:par>
                   <p:par>
-                    <p:cTn id="29" fill="hold">
+                    <p:cTn id="33" fill="hold">
                       <p:stCondLst>
                         <p:cond delay="indefinite"/>
                       </p:stCondLst>
                       <p:childTnLst>
                         <p:par>
-                          <p:cTn id="30" fill="hold">
+                          <p:cTn id="34" fill="hold">
                             <p:stCondLst>
                               <p:cond delay="0"/>
                             </p:stCondLst>
                             <p:childTnLst>
                               <p:par>
-                                <p:cTn id="31" presetID="1" presetClass="entr" presetSubtype="0" fill="hold" grpId="0" nodeType="clickEffect">
+                                <p:cTn id="35" presetID="1" presetClass="entr" presetSubtype="0" fill="hold" grpId="0" nodeType="clickEffect">
                                   <p:stCondLst>
                                     <p:cond delay="0"/>
                                   </p:stCondLst>
                                   <p:childTnLst>
                                     <p:set>
                                       <p:cBhvr>
-                                        <p:cTn id="32" dur="1" fill="hold">
+                                        <p:cTn id="36" dur="1" fill="hold">
                                           <p:stCondLst>
                                             <p:cond delay="0"/>
                                           </p:stCondLst>
                                         </p:cTn>
                                         <p:tgtEl>
-                                          <p:spTgt spid="15"/>
+                                          <p:spTgt spid="28"/>
                                         </p:tgtEl>
                                         <p:attrNameLst>
                                           <p:attrName>style.visibility</p:attrName>
@@ -5313,20 +5505,65 @@
                                 </p:cTn>
                               </p:par>
                               <p:par>
-                                <p:cTn id="33" presetID="1" presetClass="entr" presetSubtype="0" fill="hold" grpId="0" nodeType="withEffect">
+                                <p:cTn id="37" presetID="1" presetClass="entr" presetSubtype="0" fill="hold" grpId="0" nodeType="withEffect">
                                   <p:stCondLst>
                                     <p:cond delay="0"/>
                                   </p:stCondLst>
                                   <p:childTnLst>
                                     <p:set>
                                       <p:cBhvr>
-                                        <p:cTn id="34" dur="1" fill="hold">
+                                        <p:cTn id="38" dur="1" fill="hold">
                                           <p:stCondLst>
                                             <p:cond delay="0"/>
                                           </p:stCondLst>
                                         </p:cTn>
                                         <p:tgtEl>
-                                          <p:spTgt spid="16"/>
+                                          <p:spTgt spid="29"/>
+                                        </p:tgtEl>
+                                        <p:attrNameLst>
+                                          <p:attrName>style.visibility</p:attrName>
+                                        </p:attrNameLst>
+                                      </p:cBhvr>
+                                      <p:to>
+                                        <p:strVal val="visible"/>
+                                      </p:to>
+                                    </p:set>
+                                  </p:childTnLst>
+                                </p:cTn>
+                              </p:par>
+                            </p:childTnLst>
+                          </p:cTn>
+                        </p:par>
+                      </p:childTnLst>
+                    </p:cTn>
+                  </p:par>
+                  <p:par>
+                    <p:cTn id="39" fill="hold">
+                      <p:stCondLst>
+                        <p:cond delay="indefinite"/>
+                      </p:stCondLst>
+                      <p:childTnLst>
+                        <p:par>
+                          <p:cTn id="40" fill="hold">
+                            <p:stCondLst>
+                              <p:cond delay="0"/>
+                            </p:stCondLst>
+                            <p:childTnLst>
+                              <p:par>
+                                <p:cTn id="41" presetID="1" presetClass="entr" presetSubtype="0" fill="hold" grpId="0" nodeType="clickEffect">
+                                  <p:stCondLst>
+                                    <p:cond delay="0"/>
+                                  </p:stCondLst>
+                                  <p:childTnLst>
+                                    <p:set>
+                                      <p:cBhvr>
+                                        <p:cTn id="42" dur="1" fill="hold">
+                                          <p:stCondLst>
+                                            <p:cond delay="0"/>
+                                          </p:stCondLst>
+                                        </p:cTn>
+                                        <p:tgtEl>
+                                          <p:spTgt spid="30"/>
                                         </p:tgtEl>
                                         <p:attrNameLst>
                                           <p:attrName>style.visibility</p:attrName>
@@ -5340,20 +5577,20 @@
                                 </p:cTn>
                               </p:par>
                               <p:par>
-                                <p:cTn id="35" presetID="1" presetClass="entr" presetSubtype="0" fill="hold" grpId="0" nodeType="withEffect">
+                                <p:cTn id="43" presetID="1" presetClass="entr" presetSubtype="0" fill="hold" grpId="0" nodeType="withEffect">
                                   <p:stCondLst>
                                     <p:cond delay="0"/>
                                   </p:stCondLst>
                                   <p:childTnLst>
                                     <p:set>
                                       <p:cBhvr>
-                                        <p:cTn id="36" dur="1" fill="hold">
+                                        <p:cTn id="44" dur="1" fill="hold">
                                           <p:stCondLst>
                                             <p:cond delay="0"/>
                                           </p:stCondLst>
                                         </p:cTn>
                                         <p:tgtEl>
-                                          <p:spTgt spid="17"/>
+                                          <p:spTgt spid="31"/>
                                         </p:tgtEl>
                                         <p:attrNameLst>
                                           <p:attrName>style.visibility</p:attrName>
@@ -5395,16 +5632,19 @@
     </p:tnLst>
     <p:bldLst>
       <p:bldP spid="7" grpId="0"/>
-      <p:bldP spid="8" grpId="0"/>
-      <p:bldP spid="9" grpId="0" animBg="1"/>
-      <p:bldP spid="10" grpId="0"/>
-      <p:bldP spid="11" grpId="0" animBg="1"/>
-      <p:bldP spid="12" grpId="0"/>
-      <p:bldP spid="13" grpId="0" animBg="1"/>
-      <p:bldP spid="14" grpId="0"/>
       <p:bldP spid="15" grpId="0" animBg="1"/>
       <p:bldP spid="16" grpId="0"/>
       <p:bldP spid="17" grpId="0"/>
+      <p:bldP spid="22" grpId="0" animBg="1"/>
+      <p:bldP spid="23" grpId="0"/>
+      <p:bldP spid="24" grpId="0" animBg="1"/>
+      <p:bldP spid="25" grpId="0"/>
+      <p:bldP spid="26" grpId="0" animBg="1"/>
+      <p:bldP spid="27" grpId="0"/>
+      <p:bldP spid="28" grpId="0" animBg="1"/>
+      <p:bldP spid="29" grpId="0"/>
+      <p:bldP spid="30" grpId="0" animBg="1"/>
+      <p:bldP spid="31" grpId="0"/>
     </p:bldLst>
   </p:timing>
 </p:sld>
@@ -7369,46 +7609,6 @@
             <a:endParaRPr lang="en-US" sz="1400">
               <a:solidFill>
                 <a:srgbClr val="CBD5E1"/>
-              </a:solidFill>
-              <a:latin typeface="Aptos"/>
-            </a:endParaRPr>
-          </a:p>
-        </p:txBody>
-      </p:sp>
-      <p:sp>
-        <p:nvSpPr>
-          <p:cNvPr id="22" name="TextBox 21"/>
-          <p:cNvSpPr txBox="1"/>
-          <p:nvPr/>
-        </p:nvSpPr>
-        <p:spPr>
-          <a:xfrm>
-            <a:off x="558800" y="5943600"/>
-            <a:ext cx="10998200" cy="302647"/>
-          </a:xfrm>
-          <a:prstGeom prst="rect">
-            <a:avLst/>
-          </a:prstGeom>
-          <a:noFill/>
-        </p:spPr>
-        <p:txBody>
-          <a:bodyPr vert="horz" wrap="square" lIns="101600" tIns="50800" rIns="101600" bIns="50800" rtlCol="0">
-            <a:spAutoFit/>
-          </a:bodyPr>
-          <a:lstStyle/>
-          <a:p>
-            <a:r>
-              <a:rPr lang="en-US" sz="1300" smtClean="0">
-                <a:solidFill>
-                  <a:srgbClr val="94A3B8"/>
-                </a:solidFill>
-                <a:latin typeface="Aptos"/>
-              </a:rPr>
-              <a:t>Important honesty: OpenClaw manifest files are still placeholders. The real working agent currently lives under backend/agent.</a:t>
-            </a:r>
-            <a:endParaRPr lang="en-US" sz="1300">
-              <a:solidFill>
-                <a:srgbClr val="94A3B8"/>
               </a:solidFill>
               <a:latin typeface="Aptos"/>
             </a:endParaRPr>
@@ -7928,51 +8128,6 @@
                       </p:childTnLst>
                     </p:cTn>
                   </p:par>
-                  <p:par>
-                    <p:cTn id="43" fill="hold">
-                      <p:stCondLst>
-                        <p:cond delay="indefinite"/>
-                      </p:stCondLst>
-                      <p:childTnLst>
-                        <p:par>
-                          <p:cTn id="44" fill="hold">
-                            <p:stCondLst>
-                              <p:cond delay="0"/>
-                            </p:stCondLst>
-                            <p:childTnLst>
-                              <p:par>
-                                <p:cTn id="45" presetID="1" presetClass="entr" presetSubtype="0" fill="hold" grpId="0" nodeType="clickEffect">
-                                  <p:stCondLst>
-                                    <p:cond delay="0"/>
-                                  </p:stCondLst>
-                                  <p:childTnLst>
-                                    <p:set>
-                                      <p:cBhvr>
-                                        <p:cTn id="46" dur="1" fill="hold">
-                                          <p:stCondLst>
-                                            <p:cond delay="0"/>
-                                          </p:stCondLst>
-                                        </p:cTn>
-                                        <p:tgtEl>
-                                          <p:spTgt spid="22"/>
-                                        </p:tgtEl>
-                                        <p:attrNameLst>
-                                          <p:attrName>style.visibility</p:attrName>
-                                        </p:attrNameLst>
-                                      </p:cBhvr>
-                                      <p:to>
-                                        <p:strVal val="visible"/>
-                                      </p:to>
-                                    </p:set>
-                                  </p:childTnLst>
-                                </p:cTn>
-                              </p:par>
-                            </p:childTnLst>
-                          </p:cTn>
-                        </p:par>
-                      </p:childTnLst>
-                    </p:cTn>
-                  </p:par>
                 </p:childTnLst>
               </p:cTn>
               <p:prevCondLst>
@@ -8010,7 +8165,6 @@
       <p:bldP spid="19" grpId="0" animBg="1"/>
       <p:bldP spid="20" grpId="0"/>
       <p:bldP spid="21" grpId="0"/>
-      <p:bldP spid="22" grpId="0"/>
     </p:bldLst>
   </p:timing>
 </p:sld>
@@ -10982,46 +11136,6 @@
           </a:p>
         </p:txBody>
       </p:sp>
-      <p:sp>
-        <p:nvSpPr>
-          <p:cNvPr id="21" name="TextBox 20"/>
-          <p:cNvSpPr txBox="1"/>
-          <p:nvPr/>
-        </p:nvSpPr>
-        <p:spPr>
-          <a:xfrm>
-            <a:off x="558800" y="5969000"/>
-            <a:ext cx="10998200" cy="471924"/>
-          </a:xfrm>
-          <a:prstGeom prst="rect">
-            <a:avLst/>
-          </a:prstGeom>
-          <a:noFill/>
-        </p:spPr>
-        <p:txBody>
-          <a:bodyPr vert="horz" wrap="square" lIns="101600" tIns="50800" rIns="101600" bIns="50800" rtlCol="0">
-            <a:spAutoFit/>
-          </a:bodyPr>
-          <a:lstStyle/>
-          <a:p>
-            <a:r>
-              <a:rPr lang="en-US" sz="1200" smtClean="0">
-                <a:solidFill>
-                  <a:srgbClr val="94A3B8"/>
-                </a:solidFill>
-                <a:latin typeface="Aptos"/>
-              </a:rPr>
-              <a:t>Honest current state: the local DB in this workspace is empty right now, so the deck reflects verified code behavior and tests rather than a freshly populated live corpus.</a:t>
-            </a:r>
-            <a:endParaRPr lang="en-US" sz="1200">
-              <a:solidFill>
-                <a:srgbClr val="94A3B8"/>
-              </a:solidFill>
-              <a:latin typeface="Aptos"/>
-            </a:endParaRPr>
-          </a:p>
-        </p:txBody>
-      </p:sp>
     </p:spTree>
     <p:extLst>
       <p:ext uri="{BB962C8B-B14F-4D97-AF65-F5344CB8AC3E}">
@@ -11508,51 +11622,6 @@
                       </p:childTnLst>
                     </p:cTn>
                   </p:par>
-                  <p:par>
-                    <p:cTn id="41" fill="hold">
-                      <p:stCondLst>
-                        <p:cond delay="indefinite"/>
-                      </p:stCondLst>
-                      <p:childTnLst>
-                        <p:par>
-                          <p:cTn id="42" fill="hold">
-                            <p:stCondLst>
-                              <p:cond delay="0"/>
-                            </p:stCondLst>
-                            <p:childTnLst>
-                              <p:par>
-                                <p:cTn id="43" presetID="1" presetClass="entr" presetSubtype="0" fill="hold" grpId="0" nodeType="clickEffect">
-                                  <p:stCondLst>
-                                    <p:cond delay="0"/>
-                                  </p:stCondLst>
-                                  <p:childTnLst>
-                                    <p:set>
-                                      <p:cBhvr>
-                                        <p:cTn id="44" dur="1" fill="hold">
-                                          <p:stCondLst>
-                                            <p:cond delay="0"/>
-                                          </p:stCondLst>
-                                        </p:cTn>
-                                        <p:tgtEl>
-                                          <p:spTgt spid="21"/>
-                                        </p:tgtEl>
-                                        <p:attrNameLst>
-                                          <p:attrName>style.visibility</p:attrName>
-                                        </p:attrNameLst>
-                                      </p:cBhvr>
-                                      <p:to>
-                                        <p:strVal val="visible"/>
-                                      </p:to>
-                                    </p:set>
-                                  </p:childTnLst>
-                                </p:cTn>
-                              </p:par>
-                            </p:childTnLst>
-                          </p:cTn>
-                        </p:par>
-                      </p:childTnLst>
-                    </p:cTn>
-                  </p:par>
                 </p:childTnLst>
               </p:cTn>
               <p:prevCondLst>
@@ -11589,7 +11658,6 @@
       <p:bldP spid="18" grpId="0"/>
       <p:bldP spid="19" grpId="0" animBg="1"/>
       <p:bldP spid="20" grpId="0"/>
-      <p:bldP spid="21" grpId="0"/>
     </p:bldLst>
   </p:timing>
 </p:sld>
@@ -14169,7 +14237,7 @@
         <p:spPr>
           <a:xfrm>
             <a:off x="8255000" y="4089400"/>
-            <a:ext cx="2717800" cy="902811"/>
+            <a:ext cx="2717800" cy="702756"/>
           </a:xfrm>
           <a:prstGeom prst="rect">
             <a:avLst/>
@@ -14183,6 +14251,24 @@
           <a:lstStyle/>
           <a:p>
             <a:pPr algn="ctr"/>
+            <a:r>
+              <a:rPr lang="en-US" sz="1300" dirty="0" smtClean="0">
+                <a:solidFill>
+                  <a:srgbClr val="CBD5E1"/>
+                </a:solidFill>
+                <a:latin typeface="Aptos"/>
+              </a:rPr>
+              <a:t>If the agent leaves the local corpus, it uses a </a:t>
+            </a:r>
+            <a:r>
+              <a:rPr lang="en-US" sz="1300" err="1" smtClean="0">
+                <a:solidFill>
+                  <a:srgbClr val="CBD5E1"/>
+                </a:solidFill>
+                <a:latin typeface="Aptos"/>
+              </a:rPr>
+              <a:t>Firecrawl</a:t>
+            </a:r>
             <a:r>
               <a:rPr lang="en-US" sz="1300" smtClean="0">
                 <a:solidFill>
@@ -14190,9 +14276,18 @@
                 </a:solidFill>
                 <a:latin typeface="Aptos"/>
               </a:rPr>
-              <a:t>If the agent leaves the local corpus, it uses a Firecrawl-backed search that rejects non-whitelisted domains server-side.</a:t>
-            </a:r>
-            <a:endParaRPr lang="en-US" sz="1300">
+              <a:t>-backed </a:t>
+            </a:r>
+            <a:r>
+              <a:rPr lang="en-US" sz="1300" smtClean="0">
+                <a:solidFill>
+                  <a:srgbClr val="CBD5E1"/>
+                </a:solidFill>
+                <a:latin typeface="Aptos"/>
+              </a:rPr>
+              <a:t>search.</a:t>
+            </a:r>
+            <a:endParaRPr lang="en-US" sz="1300" dirty="0">
               <a:solidFill>
                 <a:srgbClr val="CBD5E1"/>
               </a:solidFill>
@@ -14261,7 +14356,7 @@
         </p:nvSpPr>
         <p:spPr>
           <a:xfrm>
-            <a:off x="1828800" y="5765800"/>
+            <a:off x="1778000" y="5648771"/>
             <a:ext cx="8458200" cy="564257"/>
           </a:xfrm>
           <a:prstGeom prst="rect">
@@ -14277,7 +14372,7 @@
           <a:p>
             <a:pPr algn="ctr"/>
             <a:r>
-              <a:rPr lang="en-US" sz="1500" b="1" smtClean="0">
+              <a:rPr lang="en-US" sz="1500" b="1" dirty="0" smtClean="0">
                 <a:solidFill>
                   <a:srgbClr val="F8FAFC"/>
                 </a:solidFill>
@@ -14285,7 +14380,7 @@
               </a:rPr>
               <a:t>If no source supports a claim, the prompt instructs the agent to mark it unsupported rather than silently inventing or deleting it.</a:t>
             </a:r>
-            <a:endParaRPr lang="en-US" sz="1500" b="1">
+            <a:endParaRPr lang="en-US" sz="1500" b="1" dirty="0">
               <a:solidFill>
                 <a:srgbClr val="F8FAFC"/>
               </a:solidFill>
@@ -14804,7 +14899,7 @@
 </file>
 
 <file path=ppt/slides/slide8.xml><?xml version="1.0" encoding="utf-8"?>
-<p:sld xmlns:a="http://schemas.openxmlformats.org/drawingml/2006/main" xmlns:r="http://schemas.openxmlformats.org/officeDocument/2006/relationships" xmlns:p="http://schemas.openxmlformats.org/presentationml/2006/main">
+<p:sld xmlns:a="http://schemas.openxmlformats.org/drawingml/2006/main" xmlns:r="http://schemas.openxmlformats.org/officeDocument/2006/relationships" xmlns:p="http://schemas.openxmlformats.org/presentationml/2006/main" show="0">
   <p:cSld>
     <p:spTree>
       <p:nvGrpSpPr>
@@ -15652,6 +15747,14 @@
   <p:clrMapOvr>
     <a:masterClrMapping/>
   </p:clrMapOvr>
+  <mc:AlternateContent xmlns:mc="http://schemas.openxmlformats.org/markup-compatibility/2006">
+    <mc:Choice xmlns:p14="http://schemas.microsoft.com/office/powerpoint/2010/main" Requires="p14">
+      <p:transition spd="slow" p14:dur="2000"/>
+    </mc:Choice>
+    <mc:Fallback>
+      <p:transition spd="slow"/>
+    </mc:Fallback>
+  </mc:AlternateContent>
   <p:timing>
     <p:tnLst>
       <p:par>
@@ -16711,47 +16814,6 @@
           </a:p>
         </p:txBody>
       </p:sp>
-      <p:sp>
-        <p:nvSpPr>
-          <p:cNvPr id="14" name="TextBox 13"/>
-          <p:cNvSpPr txBox="1"/>
-          <p:nvPr/>
-        </p:nvSpPr>
-        <p:spPr>
-          <a:xfrm>
-            <a:off x="1422400" y="5130800"/>
-            <a:ext cx="9347200" cy="595035"/>
-          </a:xfrm>
-          <a:prstGeom prst="rect">
-            <a:avLst/>
-          </a:prstGeom>
-          <a:noFill/>
-        </p:spPr>
-        <p:txBody>
-          <a:bodyPr vert="horz" wrap="square" lIns="101600" tIns="50800" rIns="101600" bIns="50800" rtlCol="0">
-            <a:spAutoFit/>
-          </a:bodyPr>
-          <a:lstStyle/>
-          <a:p>
-            <a:pPr algn="ctr"/>
-            <a:r>
-              <a:rPr lang="en-US" sz="1600" smtClean="0">
-                <a:solidFill>
-                  <a:srgbClr val="CBD5E1"/>
-                </a:solidFill>
-                <a:latin typeface="Aptos"/>
-              </a:rPr>
-              <a:t>Recommended close: show the chat flow, open the statute modal, and end on the fact that the system exposes its evidence instead of hiding it.</a:t>
-            </a:r>
-            <a:endParaRPr lang="en-US" sz="1600">
-              <a:solidFill>
-                <a:srgbClr val="CBD5E1"/>
-              </a:solidFill>
-              <a:latin typeface="Aptos"/>
-            </a:endParaRPr>
-          </a:p>
-        </p:txBody>
-      </p:sp>
     </p:spTree>
     <p:extLst>
       <p:ext uri="{BB962C8B-B14F-4D97-AF65-F5344CB8AC3E}">
@@ -17031,51 +17093,6 @@
                       </p:childTnLst>
                     </p:cTn>
                   </p:par>
-                  <p:par>
-                    <p:cTn id="25" fill="hold">
-                      <p:stCondLst>
-                        <p:cond delay="indefinite"/>
-                      </p:stCondLst>
-                      <p:childTnLst>
-                        <p:par>
-                          <p:cTn id="26" fill="hold">
-                            <p:stCondLst>
-                              <p:cond delay="0"/>
-                            </p:stCondLst>
-                            <p:childTnLst>
-                              <p:par>
-                                <p:cTn id="27" presetID="1" presetClass="entr" presetSubtype="0" fill="hold" grpId="0" nodeType="clickEffect">
-                                  <p:stCondLst>
-                                    <p:cond delay="0"/>
-                                  </p:stCondLst>
-                                  <p:childTnLst>
-                                    <p:set>
-                                      <p:cBhvr>
-                                        <p:cTn id="28" dur="1" fill="hold">
-                                          <p:stCondLst>
-                                            <p:cond delay="0"/>
-                                          </p:stCondLst>
-                                        </p:cTn>
-                                        <p:tgtEl>
-                                          <p:spTgt spid="14"/>
-                                        </p:tgtEl>
-                                        <p:attrNameLst>
-                                          <p:attrName>style.visibility</p:attrName>
-                                        </p:attrNameLst>
-                                      </p:cBhvr>
-                                      <p:to>
-                                        <p:strVal val="visible"/>
-                                      </p:to>
-                                    </p:set>
-                                  </p:childTnLst>
-                                </p:cTn>
-                              </p:par>
-                            </p:childTnLst>
-                          </p:cTn>
-                        </p:par>
-                      </p:childTnLst>
-                    </p:cTn>
-                  </p:par>
                 </p:childTnLst>
               </p:cTn>
               <p:prevCondLst>
@@ -17105,7 +17122,6 @@
       <p:bldP spid="11" grpId="0"/>
       <p:bldP spid="12" grpId="0"/>
       <p:bldP spid="13" grpId="0"/>
-      <p:bldP spid="14" grpId="0"/>
     </p:bldLst>
   </p:timing>
 </p:sld>

</xml_diff>